<commit_message>
feat: generalizar el análisis a cualquier canción (3 casos reales)
- Script con funciones y datos en CSV (datos/), tabla y gráfico comparativos
- Validación del pico de la cúbica (a < 0 y dentro del rango)
- Casos: Rosa Pastel, Ella Baila Sola y Tití Me Preguntó (Spotify México, kworb.net)
- Informe, presentación y README actualizados con la generalización

Co-Authored-By: Claude Opus 5.5 <noreply@anthropic.com>
</commit_message>
<xml_diff>
--- a/Presentacion_Rosa_Pastel_Metodos_Numericos.pptx
+++ b/Presentacion_Rosa_Pastel_Metodos_Numericos.pptx
@@ -15,6 +15,7 @@
     <p:sldId id="263" r:id="rId14"/>
     <p:sldId id="264" r:id="rId15"/>
     <p:sldId id="265" r:id="rId16"/>
+    <p:sldId id="266" r:id="rId17"/>
   </p:sldIdLst>
   <p:sldSz cx="12191695" cy="6858000" type="screen4x3"/>
   <p:notesSz cx="6858000" cy="9144000"/>
@@ -3248,6 +3249,167 @@
       <p:grpSpPr/>
       <p:sp>
         <p:nvSpPr>
+          <p:cNvPr id="2" name="TextBox 1"/>
+          <p:cNvSpPr txBox="1"/>
+          <p:nvPr/>
+        </p:nvSpPr>
+        <p:spPr>
+          <a:xfrm>
+            <a:off x="731520" y="365760"/>
+            <a:ext cx="10698480" cy="1005840"/>
+          </a:xfrm>
+          <a:prstGeom prst="rect">
+            <a:avLst/>
+          </a:prstGeom>
+          <a:noFill/>
+        </p:spPr>
+        <p:txBody>
+          <a:bodyPr wrap="square" lIns="0" tIns="0" rIns="0" bIns="0">
+            <a:spAutoFit/>
+          </a:bodyPr>
+          <a:lstStyle/>
+          <a:p>
+            <a:pPr>
+              <a:defRPr sz="1100" b="1">
+                <a:solidFill>
+                  <a:srgbClr val="E91E63"/>
+                </a:solidFill>
+                <a:latin typeface="Calibri"/>
+              </a:defRPr>
+            </a:pPr>
+            <a:r>
+              <a:t>SÍNTESIS FINAL</a:t>
+            </a:r>
+          </a:p>
+          <a:p>
+            <a:pPr>
+              <a:defRPr sz="2300" b="1">
+                <a:solidFill>
+                  <a:srgbClr val="1F4E79"/>
+                </a:solidFill>
+                <a:latin typeface="Calibri"/>
+              </a:defRPr>
+            </a:pPr>
+            <a:r>
+              <a:t>Conclusiones del Proyecto Integrador</a:t>
+            </a:r>
+          </a:p>
+        </p:txBody>
+      </p:sp>
+      <p:sp>
+        <p:nvSpPr>
+          <p:cNvPr id="3" name="Rounded Rectangle 2"/>
+          <p:cNvSpPr/>
+          <p:nvPr/>
+        </p:nvSpPr>
+        <p:spPr>
+          <a:xfrm>
+            <a:off x="731520" y="1645920"/>
+            <a:ext cx="10698480" cy="4663440"/>
+          </a:xfrm>
+          <a:prstGeom prst="roundRect">
+            <a:avLst/>
+          </a:prstGeom>
+          <a:solidFill>
+            <a:srgbClr val="F5F7FA"/>
+          </a:solidFill>
+          <a:ln>
+            <a:solidFill>
+              <a:srgbClr val="D9E1F2"/>
+            </a:solidFill>
+          </a:ln>
+        </p:spPr>
+        <p:style>
+          <a:lnRef idx="1">
+            <a:schemeClr val="accent1"/>
+          </a:lnRef>
+          <a:fillRef idx="3">
+            <a:schemeClr val="accent1"/>
+          </a:fillRef>
+          <a:effectRef idx="2">
+            <a:schemeClr val="accent1"/>
+          </a:effectRef>
+          <a:fontRef idx="minor">
+            <a:schemeClr val="lt1"/>
+          </a:fontRef>
+        </p:style>
+        <p:txBody>
+          <a:bodyPr rtlCol="0" anchor="ctr" wrap="square" lIns="365760" tIns="365760"/>
+          <a:lstStyle/>
+          <a:p>
+            <a:pPr algn="ctr">
+              <a:spcAft>
+                <a:spcPts val="1000"/>
+              </a:spcAft>
+              <a:defRPr sz="1700" b="1">
+                <a:solidFill>
+                  <a:srgbClr val="1F4E79"/>
+                </a:solidFill>
+              </a:defRPr>
+            </a:pPr>
+            <a:r>
+              <a:t>Principales Aprendizajes y Conclusiones:</a:t>
+            </a:r>
+          </a:p>
+          <a:p>
+            <a:pPr>
+              <a:defRPr sz="1100">
+                <a:solidFill>
+                  <a:srgbClr val="282828"/>
+                </a:solidFill>
+              </a:defRPr>
+            </a:pPr>
+            <a:r>
+              <a:t>1. Ajuste confiable: La regresión polinómica cúbica ofreció una muy buena aproximación global (R² = 0.9995, Sy/x = 0.927 M) para representar la acumulación de reproducciones a lo largo del año.</a:t>
+            </a:r>
+            <a:br/>
+            <a:br/>
+            <a:r>
+              <a:t>2. Eficiencia comparada de raíces: Newton-Raphson demostró ser 5 veces más rápido que Bisección (3 iteraciones frente a 15) para alcanzar la tolerancia de 10⁻⁴ %, convergiendo a la misma raíz (t* ≈ 35.52 semanas).</a:t>
+            </a:r>
+            <a:br/>
+            <a:br/>
+            <a:r>
+              <a:t>3. Validación del modelo: La discrepancia de 2.75 días respecto a la interpolación lineal directa confirma la coherencia física y estadística del ajuste dentro del error estándar.</a:t>
+            </a:r>
+            <a:br/>
+            <a:br/>
+            <a:r>
+              <a:t>4. Dinámica del consumo: La diferenciación numérica reveló que el pico real de streams ocurrió en la semana 26 (fines de julio de 2023, 4.171 M), y evidenció cómo el modelo cúbico suaviza la respuesta temporal.</a:t>
+            </a:r>
+            <a:br/>
+            <a:br/>
+            <a:r>
+              <a:t>5. Aporte a la ingeniería: El modelado numérico permite convertir datos discretos de telemetría en funciones continuas útiles para dimensionar infraestructura y servidores de streaming ante variaciones de demanda.</a:t>
+            </a:r>
+            <a:br/>
+            <a:br/>
+            <a:r>
+              <a:t>6. Generalización y validación automática: El método resultó reutilizable para otras canciones; demostró que un R² alto (&gt; 0.996) no basta para validar un modelo físico y que el sistema alerta cuándo la cúbica no aplica (estrenos con a &gt; 0).</a:t>
+            </a:r>
+          </a:p>
+        </p:txBody>
+      </p:sp>
+    </p:spTree>
+  </p:cSld>
+  <p:clrMapOvr>
+    <a:masterClrMapping/>
+  </p:clrMapOvr>
+</p:sld>
+</file>
+
+<file path=ppt/slides/slide11.xml><?xml version="1.0" encoding="utf-8"?>
+<p:sld xmlns:a="http://schemas.openxmlformats.org/drawingml/2006/main" xmlns:p="http://schemas.openxmlformats.org/presentationml/2006/main" xmlns:r="http://schemas.openxmlformats.org/officeDocument/2006/relationships">
+  <p:cSld>
+    <p:spTree>
+      <p:nvGrpSpPr>
+        <p:cNvPr id="1" name=""/>
+        <p:cNvGrpSpPr/>
+        <p:nvPr/>
+      </p:nvGrpSpPr>
+      <p:grpSpPr/>
+      <p:sp>
+        <p:nvSpPr>
           <p:cNvPr id="2" name="Rectangle 1"/>
           <p:cNvSpPr/>
           <p:nvPr/>
@@ -4632,6 +4794,194 @@
               </a:defRPr>
             </a:pPr>
             <a:r>
+              <a:t>VALIDACIÓN DEL MODELO Y GENERALIZACIÓN</a:t>
+            </a:r>
+          </a:p>
+          <a:p>
+            <a:pPr>
+              <a:defRPr sz="2300" b="1">
+                <a:solidFill>
+                  <a:srgbClr val="1F4E79"/>
+                </a:solidFill>
+                <a:latin typeface="Calibri"/>
+              </a:defRPr>
+            </a:pPr>
+            <a:r>
+              <a:t>Generalización: ¿sirve para cualquier canción?</a:t>
+            </a:r>
+          </a:p>
+        </p:txBody>
+      </p:sp>
+      <p:sp>
+        <p:nvSpPr>
+          <p:cNvPr id="3" name="TextBox 2"/>
+          <p:cNvSpPr txBox="1"/>
+          <p:nvPr/>
+        </p:nvSpPr>
+        <p:spPr>
+          <a:xfrm>
+            <a:off x="731520" y="1645920"/>
+            <a:ext cx="6400800" cy="4663440"/>
+          </a:xfrm>
+          <a:prstGeom prst="rect">
+            <a:avLst/>
+          </a:prstGeom>
+          <a:noFill/>
+        </p:spPr>
+        <p:txBody>
+          <a:bodyPr wrap="square">
+            <a:spAutoFit/>
+          </a:bodyPr>
+          <a:lstStyle/>
+          <a:p>
+            <a:pPr>
+              <a:spcAft>
+                <a:spcPts val="800"/>
+              </a:spcAft>
+              <a:defRPr sz="1500" b="1">
+                <a:solidFill>
+                  <a:srgbClr val="1F4E79"/>
+                </a:solidFill>
+              </a:defRPr>
+            </a:pPr>
+            <a:r>
+              <a:t>Evaluación en 3 Canciones (Resurgimiento vs. Estrenos):</a:t>
+            </a:r>
+          </a:p>
+          <a:p>
+            <a:pPr>
+              <a:defRPr sz="1100">
+                <a:solidFill>
+                  <a:srgbClr val="282828"/>
+                </a:solidFill>
+              </a:defRPr>
+            </a:pPr>
+            <a:r>
+              <a:t>• Regla matemática de validación:</a:t>
+            </a:r>
+            <a:br/>
+            <a:r>
+              <a:t>  - Punto de inflexión: t = -b / (3a). Es MÁXIMO del ritmo S'(t) sólo si a &lt; 0.</a:t>
+            </a:r>
+            <a:br/>
+            <a:r>
+              <a:t>  - Si a &gt; 0, es un MÍNIMO: la cúbica no puede representar el pico de demanda.</a:t>
+            </a:r>
+            <a:br/>
+            <a:br/>
+            <a:r>
+              <a:t>• Resurgimiento gradual vs. Estrenos masivos:</a:t>
+            </a:r>
+            <a:br/>
+            <a:r>
+              <a:t>  - Rosa Pastel: sube meses y baja (a = -0.000839 &lt; 0) → Aplica (pico en sem. 30.6).</a:t>
+            </a:r>
+            <a:br/>
+            <a:r>
+              <a:t>  - Estrenos (Ella Baila Sola, Tití): arrancan en pico y sólo bajan (a &gt; 0) → No aplica.</a:t>
+            </a:r>
+            <a:br/>
+            <a:r>
+              <a:t>    La derivada parabólica vuelve a subir al final (rebote irreal en el gráfico).</a:t>
+            </a:r>
+            <a:br/>
+            <a:br/>
+            <a:r>
+              <a:t>• Un R² alto no garantiza validez física:</a:t>
+            </a:r>
+            <a:br/>
+            <a:r>
+              <a:t>  - En los estrenos R² es casi perfecto (0.996 y 0.9997), pero el modelo falla para el pico.</a:t>
+            </a:r>
+            <a:br/>
+            <a:br/>
+            <a:r>
+              <a:t>• Herramienta general de ingeniería reutilizable:</a:t>
+            </a:r>
+            <a:br/>
+            <a:r>
+              <a:t>  - Hito 100M (Newton en 3 iteraciones) y pico de datos funcionan para todas.</a:t>
+            </a:r>
+            <a:br/>
+            <a:r>
+              <a:t>  - El programa avisa automáticamente cuándo no aplica en lugar de arrojar un resultado falso.</a:t>
+            </a:r>
+          </a:p>
+        </p:txBody>
+      </p:sp>
+      <p:pic>
+        <p:nvPicPr>
+          <p:cNvPr id="4" name="Picture 3" descr="grafico_4_comparacion_canciones.png"/>
+          <p:cNvPicPr>
+            <a:picLocks noChangeAspect="1"/>
+          </p:cNvPicPr>
+          <p:nvPr/>
+        </p:nvPicPr>
+        <p:blipFill>
+          <a:blip r:embed="rId2"/>
+          <a:stretch>
+            <a:fillRect/>
+          </a:stretch>
+        </p:blipFill>
+        <p:spPr>
+          <a:xfrm>
+            <a:off x="7406640" y="1645920"/>
+            <a:ext cx="3886200" cy="4663440"/>
+          </a:xfrm>
+          <a:prstGeom prst="rect">
+            <a:avLst/>
+          </a:prstGeom>
+        </p:spPr>
+      </p:pic>
+    </p:spTree>
+  </p:cSld>
+  <p:clrMapOvr>
+    <a:masterClrMapping/>
+  </p:clrMapOvr>
+</p:sld>
+</file>
+
+<file path=ppt/slides/slide9.xml><?xml version="1.0" encoding="utf-8"?>
+<p:sld xmlns:a="http://schemas.openxmlformats.org/drawingml/2006/main" xmlns:p="http://schemas.openxmlformats.org/presentationml/2006/main" xmlns:r="http://schemas.openxmlformats.org/officeDocument/2006/relationships">
+  <p:cSld>
+    <p:spTree>
+      <p:nvGrpSpPr>
+        <p:cNvPr id="1" name=""/>
+        <p:cNvGrpSpPr/>
+        <p:nvPr/>
+      </p:nvGrpSpPr>
+      <p:grpSpPr/>
+      <p:sp>
+        <p:nvSpPr>
+          <p:cNvPr id="2" name="TextBox 1"/>
+          <p:cNvSpPr txBox="1"/>
+          <p:nvPr/>
+        </p:nvSpPr>
+        <p:spPr>
+          <a:xfrm>
+            <a:off x="731520" y="365760"/>
+            <a:ext cx="10698480" cy="1005840"/>
+          </a:xfrm>
+          <a:prstGeom prst="rect">
+            <a:avLst/>
+          </a:prstGeom>
+          <a:noFill/>
+        </p:spPr>
+        <p:txBody>
+          <a:bodyPr wrap="square" lIns="0" tIns="0" rIns="0" bIns="0">
+            <a:spAutoFit/>
+          </a:bodyPr>
+          <a:lstStyle/>
+          <a:p>
+            <a:pPr>
+              <a:defRPr sz="1100" b="1">
+                <a:solidFill>
+                  <a:srgbClr val="E91E63"/>
+                </a:solidFill>
+                <a:latin typeface="Calibri"/>
+              </a:defRPr>
+            </a:pPr>
+            <a:r>
               <a:t>ANÁLISIS CRÍTICO</a:t>
             </a:r>
           </a:p>
@@ -4922,162 +5272,6 @@
             </a:pPr>
             <a:r>
               <a:t>El modelo cúbico solo es válido dentro del rango de 2023 (t ∈ [0, 46]). Dado que su coeficiente cúbico es negativo (a = -0.000839), extrapolar fuera del año haría tender los streams acumulados a -∞.</a:t>
-            </a:r>
-          </a:p>
-        </p:txBody>
-      </p:sp>
-    </p:spTree>
-  </p:cSld>
-  <p:clrMapOvr>
-    <a:masterClrMapping/>
-  </p:clrMapOvr>
-</p:sld>
-</file>
-
-<file path=ppt/slides/slide9.xml><?xml version="1.0" encoding="utf-8"?>
-<p:sld xmlns:a="http://schemas.openxmlformats.org/drawingml/2006/main" xmlns:p="http://schemas.openxmlformats.org/presentationml/2006/main" xmlns:r="http://schemas.openxmlformats.org/officeDocument/2006/relationships">
-  <p:cSld>
-    <p:spTree>
-      <p:nvGrpSpPr>
-        <p:cNvPr id="1" name=""/>
-        <p:cNvGrpSpPr/>
-        <p:nvPr/>
-      </p:nvGrpSpPr>
-      <p:grpSpPr/>
-      <p:sp>
-        <p:nvSpPr>
-          <p:cNvPr id="2" name="TextBox 1"/>
-          <p:cNvSpPr txBox="1"/>
-          <p:nvPr/>
-        </p:nvSpPr>
-        <p:spPr>
-          <a:xfrm>
-            <a:off x="731520" y="365760"/>
-            <a:ext cx="10698480" cy="1005840"/>
-          </a:xfrm>
-          <a:prstGeom prst="rect">
-            <a:avLst/>
-          </a:prstGeom>
-          <a:noFill/>
-        </p:spPr>
-        <p:txBody>
-          <a:bodyPr wrap="square" lIns="0" tIns="0" rIns="0" bIns="0">
-            <a:spAutoFit/>
-          </a:bodyPr>
-          <a:lstStyle/>
-          <a:p>
-            <a:pPr>
-              <a:defRPr sz="1100" b="1">
-                <a:solidFill>
-                  <a:srgbClr val="E91E63"/>
-                </a:solidFill>
-                <a:latin typeface="Calibri"/>
-              </a:defRPr>
-            </a:pPr>
-            <a:r>
-              <a:t>SÍNTESIS FINAL</a:t>
-            </a:r>
-          </a:p>
-          <a:p>
-            <a:pPr>
-              <a:defRPr sz="2300" b="1">
-                <a:solidFill>
-                  <a:srgbClr val="1F4E79"/>
-                </a:solidFill>
-                <a:latin typeface="Calibri"/>
-              </a:defRPr>
-            </a:pPr>
-            <a:r>
-              <a:t>Conclusiones del Proyecto Integrador</a:t>
-            </a:r>
-          </a:p>
-        </p:txBody>
-      </p:sp>
-      <p:sp>
-        <p:nvSpPr>
-          <p:cNvPr id="3" name="Rounded Rectangle 2"/>
-          <p:cNvSpPr/>
-          <p:nvPr/>
-        </p:nvSpPr>
-        <p:spPr>
-          <a:xfrm>
-            <a:off x="731520" y="1645920"/>
-            <a:ext cx="10698480" cy="4663440"/>
-          </a:xfrm>
-          <a:prstGeom prst="roundRect">
-            <a:avLst/>
-          </a:prstGeom>
-          <a:solidFill>
-            <a:srgbClr val="F5F7FA"/>
-          </a:solidFill>
-          <a:ln>
-            <a:solidFill>
-              <a:srgbClr val="D9E1F2"/>
-            </a:solidFill>
-          </a:ln>
-        </p:spPr>
-        <p:style>
-          <a:lnRef idx="1">
-            <a:schemeClr val="accent1"/>
-          </a:lnRef>
-          <a:fillRef idx="3">
-            <a:schemeClr val="accent1"/>
-          </a:fillRef>
-          <a:effectRef idx="2">
-            <a:schemeClr val="accent1"/>
-          </a:effectRef>
-          <a:fontRef idx="minor">
-            <a:schemeClr val="lt1"/>
-          </a:fontRef>
-        </p:style>
-        <p:txBody>
-          <a:bodyPr rtlCol="0" anchor="ctr" wrap="square" lIns="365760" tIns="365760"/>
-          <a:lstStyle/>
-          <a:p>
-            <a:pPr algn="ctr">
-              <a:spcAft>
-                <a:spcPts val="1200"/>
-              </a:spcAft>
-              <a:defRPr sz="1700" b="1">
-                <a:solidFill>
-                  <a:srgbClr val="1F4E79"/>
-                </a:solidFill>
-              </a:defRPr>
-            </a:pPr>
-            <a:r>
-              <a:t>Principales Aprendizajes y Conclusiones:</a:t>
-            </a:r>
-          </a:p>
-          <a:p>
-            <a:pPr>
-              <a:defRPr sz="1250">
-                <a:solidFill>
-                  <a:srgbClr val="282828"/>
-                </a:solidFill>
-              </a:defRPr>
-            </a:pPr>
-            <a:r>
-              <a:t>1. Ajuste confiable: La regresión polinómica cúbica ofreció una muy buena aproximación global (R² = 0.9995, Sy/x = 0.927 M) para representar la acumulación de reproducciones a lo largo del año.</a:t>
-            </a:r>
-            <a:br/>
-            <a:br/>
-            <a:r>
-              <a:t>2. Eficiencia comparada de raíces: Newton-Raphson demostró ser 5 veces más rápido que Bisección (3 iteraciones frente a 15) para alcanzar la tolerancia de 10⁻⁴ %, convergiendo a la misma raíz (t* ≈ 35.52 semanas).</a:t>
-            </a:r>
-            <a:br/>
-            <a:br/>
-            <a:r>
-              <a:t>3. Validación del modelo: La discrepancia de 2.75 días respecto a la interpolación lineal directa confirma la coherencia física y estadística del ajuste dentro del error estándar.</a:t>
-            </a:r>
-            <a:br/>
-            <a:br/>
-            <a:r>
-              <a:t>4. Dinámica del consumo: La diferenciación numérica reveló que el pico real de streams ocurrió en la semana 26 (fines de julio de 2023, 4.171 M), y evidenció cómo el modelo cúbico suaviza la respuesta temporal.</a:t>
-            </a:r>
-            <a:br/>
-            <a:br/>
-            <a:r>
-              <a:t>5. Aporte a la ingeniería: El modelado numérico permite convertir datos discretos de telemetría en funciones continuas útiles para dimensionar infraestructura y servidores de streaming ante variaciones de demanda.</a:t>
             </a:r>
           </a:p>
         </p:txBody>

</xml_diff>